<commit_message>
docs: refresh the slides with the trusted-list trust store and the current test count
</commit_message>
<xml_diff>
--- a/docs/PDF-Inspector-TFM.pptx
+++ b/docs/PDF-Inspector-TFM.pptx
@@ -1134,7 +1134,7 @@
           <a:p>
             <a:r>
               <a:rPr lang="en-US" dirty="0"/>
-              <a:t>La carga automática de las listas de confianza (TSL) queda como trabajo futuro. Los subfiltros no soportados se informan como UNSUPPORTED en vez de fallar.</a:t>
+              <a:t>Las anclas no se descargan en el servidor: una herramienta de mantenimiento descarga la LOTL de la UE y la TSL española, verifica sus firmas XML contra certificados fijados por huella y regenera el almacén; un job semanal de GitHub Actions abre un PR cuando la lista cambia. Hoy son 145 anclas: 77 CA cualificadas para firma y 68 TSA cualificadas. Ampliar a otros países sería seguir los demás punteros de la LOTL. Subfiltros de firma admitidos: PKCS#7 y CAdES separados; el resto se informa como UNSUPPORTED. El dominio no depende de ninguna librería.</a:t>
             </a:r>
             <a:endParaRPr lang="en-US" dirty="0"/>
           </a:p>
@@ -2150,6 +2150,102 @@
           <a:chExt cx="0" cy="0"/>
         </a:xfrm>
       </p:grpSpPr>
+      <p:sp>
+        <p:nvSpPr>
+          <p:cNvPr id="2" name="Title Placeholder 1"/>
+          <p:cNvSpPr/>
+          <p:nvPr>
+            <p:ph type="title"/>
+          </p:nvPr>
+        </p:nvSpPr>
+        <p:spPr>
+          <a:xfrm>
+            <a:off x="812800" y="1163241"/>
+            <a:ext cx="10566400" cy="502841"/>
+          </a:xfrm>
+          <a:prstGeom prst="rect">
+            <a:avLst/>
+          </a:prstGeom>
+          <a:noFill/>
+          <a:ln/>
+        </p:spPr>
+        <p:txBody>
+          <a:bodyPr wrap="square" lIns="0" tIns="0" rIns="0" bIns="0" rtlCol="0" anchor="t"/>
+          <a:lstStyle>
+            <a:lvl1pPr algn="l" indent="0" marL="0">
+              <a:lnSpc>
+                <a:spcPct val="115000"/>
+              </a:lnSpc>
+              <a:buNone/>
+              <a:defRPr lang="en-US" sz="3600" dirty="0">
+                <a:solidFill>
+                  <a:srgbClr val="14213D"/>
+                </a:solidFill>
+                <a:latin typeface="Source Serif 4" pitchFamily="34" charset="0"/>
+                <a:ea typeface="Source Serif 4" pitchFamily="34" charset="-122"/>
+                <a:cs typeface="Source Serif 4" pitchFamily="34" charset="-120"/>
+              </a:defRPr>
+            </a:lvl1pPr>
+          </a:lstStyle>
+          <a:p>
+            <a:pPr algn="l" indent="0" marL="0">
+              <a:lnSpc>
+                <a:spcPct val="115000"/>
+              </a:lnSpc>
+              <a:buNone/>
+            </a:pPr>
+            <a:endParaRPr lang="en-US" sz="3600" dirty="0"/>
+          </a:p>
+        </p:txBody>
+      </p:sp>
+      <p:sp>
+        <p:nvSpPr>
+          <p:cNvPr id="3" name="Text Placeholder 2"/>
+          <p:cNvSpPr/>
+          <p:nvPr>
+            <p:ph idx="101" type="body"/>
+          </p:nvPr>
+        </p:nvSpPr>
+        <p:spPr>
+          <a:xfrm>
+            <a:off x="812800" y="1970881"/>
+            <a:ext cx="10566400" cy="4074319"/>
+          </a:xfrm>
+          <a:prstGeom prst="rect">
+            <a:avLst/>
+          </a:prstGeom>
+          <a:noFill/>
+          <a:ln/>
+        </p:spPr>
+        <p:txBody>
+          <a:bodyPr wrap="square" lIns="0" tIns="0" rIns="0" bIns="0" rtlCol="0" anchor="t"/>
+          <a:lstStyle>
+            <a:lvl1pPr algn="l" indent="0" marL="0">
+              <a:lnSpc>
+                <a:spcPct val="140000"/>
+              </a:lnSpc>
+              <a:buNone/>
+              <a:defRPr lang="en-US" sz="1600" dirty="0">
+                <a:solidFill>
+                  <a:srgbClr val="14213D"/>
+                </a:solidFill>
+                <a:latin typeface="IBM Plex Sans" pitchFamily="34" charset="0"/>
+                <a:ea typeface="IBM Plex Sans" pitchFamily="34" charset="-122"/>
+                <a:cs typeface="IBM Plex Sans" pitchFamily="34" charset="-120"/>
+              </a:defRPr>
+            </a:lvl1pPr>
+          </a:lstStyle>
+          <a:p>
+            <a:pPr algn="l" indent="0" marL="0">
+              <a:lnSpc>
+                <a:spcPct val="140000"/>
+              </a:lnSpc>
+              <a:buNone/>
+            </a:pPr>
+            <a:endParaRPr lang="en-US" sz="1600" dirty="0"/>
+          </a:p>
+        </p:txBody>
+      </p:sp>
     </p:spTree>
   </p:cSld>
   <p:clrMap bg1="lt1" tx1="dk1" bg2="lt2" tx2="dk2" accent1="accent1" accent2="accent2" accent3="accent3" accent4="accent4" accent5="accent5" accent6="accent6" hlink="hlink" folHlink="folHlink"/>
@@ -4845,7 +4941,7 @@
                 <a:ea typeface="IBM Plex Sans" pitchFamily="34" charset="-122"/>
                 <a:cs typeface="IBM Plex Sans" pitchFamily="34" charset="-120"/>
               </a:rPr>
-              <a:t>486</a:t>
+              <a:t>528</a:t>
             </a:r>
             <a:endParaRPr lang="en-US" sz="6000" dirty="0"/>
           </a:p>
@@ -7224,11 +7320,11 @@
         <p:spPr>
           <a:xfrm>
             <a:off x="815975" y="1974056"/>
-            <a:ext cx="5175250" cy="2724150"/>
+            <a:ext cx="5175250" cy="2990850"/>
           </a:xfrm>
           <a:prstGeom prst="roundRect">
             <a:avLst>
-              <a:gd name="adj" fmla="val 3613"/>
+              <a:gd name="adj" fmla="val 3291"/>
             </a:avLst>
           </a:prstGeom>
           <a:solidFill>
@@ -7383,7 +7479,7 @@
         <p:spPr>
           <a:xfrm>
             <a:off x="1073150" y="3907631"/>
-            <a:ext cx="4800727" cy="292100"/>
+            <a:ext cx="4800727" cy="825500"/>
           </a:xfrm>
           <a:prstGeom prst="rect">
             <a:avLst/>
@@ -7412,7 +7508,7 @@
                 <a:ea typeface="IBM Plex Sans" pitchFamily="34" charset="-122"/>
                 <a:cs typeface="IBM Plex Sans" pitchFamily="34" charset="-120"/>
               </a:rPr>
-              <a:t>El dominio no depende de ninguna librería.</a:t>
+              <a:t>Anclas de confianza generadas de la Lista de Confianza oficial, con firma verificada y actualización semanal.</a:t>
             </a:r>
             <a:endParaRPr lang="en-US" sz="1500" dirty="0"/>
           </a:p>
@@ -7427,11 +7523,11 @@
         <p:spPr>
           <a:xfrm>
             <a:off x="6200775" y="1974056"/>
-            <a:ext cx="5175250" cy="2724150"/>
+            <a:ext cx="5175250" cy="2990850"/>
           </a:xfrm>
           <a:prstGeom prst="roundRect">
             <a:avLst>
-              <a:gd name="adj" fmla="val 3613"/>
+              <a:gd name="adj" fmla="val 3291"/>
             </a:avLst>
           </a:prstGeom>
           <a:solidFill>
@@ -7615,7 +7711,7 @@
                 <a:ea typeface="IBM Plex Sans" pitchFamily="34" charset="-122"/>
                 <a:cs typeface="IBM Plex Sans" pitchFamily="34" charset="-120"/>
               </a:rPr>
-              <a:t>Subfiltros de firma admitidos: PKCS#7 y CAdES separados.</a:t>
+              <a:t>Solo confía en CA españolas: las de otros países de la UE salen como no admitidas.</a:t>
             </a:r>
             <a:endParaRPr lang="en-US" sz="1500" dirty="0"/>
           </a:p>
@@ -8676,11 +8772,11 @@
         <p:spPr>
           <a:xfrm>
             <a:off x="815975" y="1974056"/>
-            <a:ext cx="3397250" cy="1215330"/>
+            <a:ext cx="3397250" cy="1455341"/>
           </a:xfrm>
           <a:prstGeom prst="roundRect">
             <a:avLst>
-              <a:gd name="adj" fmla="val 8099"/>
+              <a:gd name="adj" fmla="val 6763"/>
             </a:avLst>
           </a:prstGeom>
           <a:solidFill>
@@ -8813,11 +8909,11 @@
         <p:spPr>
           <a:xfrm>
             <a:off x="4397375" y="1974056"/>
-            <a:ext cx="3397250" cy="1215330"/>
+            <a:ext cx="3397250" cy="1455341"/>
           </a:xfrm>
           <a:prstGeom prst="roundRect">
             <a:avLst>
-              <a:gd name="adj" fmla="val 8099"/>
+              <a:gd name="adj" fmla="val 6763"/>
             </a:avLst>
           </a:prstGeom>
           <a:solidFill>
@@ -8928,11 +9024,11 @@
         <p:spPr>
           <a:xfrm>
             <a:off x="7978775" y="1974056"/>
-            <a:ext cx="3397250" cy="1215330"/>
+            <a:ext cx="3397250" cy="1455341"/>
           </a:xfrm>
           <a:prstGeom prst="roundRect">
             <a:avLst>
-              <a:gd name="adj" fmla="val 8099"/>
+              <a:gd name="adj" fmla="val 6763"/>
             </a:avLst>
           </a:prstGeom>
           <a:solidFill>
@@ -8999,7 +9095,7 @@
         <p:spPr>
           <a:xfrm>
             <a:off x="8185150" y="2502991"/>
-            <a:ext cx="3074035" cy="505420"/>
+            <a:ext cx="3074035" cy="745430"/>
           </a:xfrm>
           <a:prstGeom prst="rect">
             <a:avLst/>
@@ -9028,7 +9124,7 @@
                 <a:ea typeface="IBM Plex Sans" pitchFamily="34" charset="-122"/>
                 <a:cs typeface="IBM Plex Sans" pitchFamily="34" charset="-120"/>
               </a:rPr>
-              <a:t>Validación PKIX contra un almacén de confianza configurable.</a:t>
+              <a:t>Validación PKIX contra las CA y TSA cualificadas de la Lista de Confianza española.</a:t>
             </a:r>
             <a:endParaRPr lang="en-US" sz="1400" dirty="0"/>
           </a:p>
@@ -9042,7 +9138,7 @@
         </p:nvSpPr>
         <p:spPr>
           <a:xfrm>
-            <a:off x="815975" y="3373537"/>
+            <a:off x="815975" y="3613547"/>
             <a:ext cx="3397250" cy="1215330"/>
           </a:xfrm>
           <a:prstGeom prst="roundRect">
@@ -9069,7 +9165,7 @@
         </p:nvSpPr>
         <p:spPr>
           <a:xfrm>
-            <a:off x="1022350" y="3579912"/>
+            <a:off x="1022350" y="3819922"/>
             <a:ext cx="3074035" cy="284460"/>
           </a:xfrm>
           <a:prstGeom prst="rect">
@@ -9113,7 +9209,7 @@
         </p:nvSpPr>
         <p:spPr>
           <a:xfrm>
-            <a:off x="1022350" y="3902472"/>
+            <a:off x="1022350" y="4142482"/>
             <a:ext cx="3074035" cy="505420"/>
           </a:xfrm>
           <a:prstGeom prst="rect">
@@ -9157,7 +9253,7 @@
         </p:nvSpPr>
         <p:spPr>
           <a:xfrm>
-            <a:off x="4397375" y="3373537"/>
+            <a:off x="4397375" y="3613547"/>
             <a:ext cx="3397250" cy="1215330"/>
           </a:xfrm>
           <a:prstGeom prst="roundRect">
@@ -9184,7 +9280,7 @@
         </p:nvSpPr>
         <p:spPr>
           <a:xfrm>
-            <a:off x="4603750" y="3579912"/>
+            <a:off x="4603750" y="3819922"/>
             <a:ext cx="3074035" cy="284460"/>
           </a:xfrm>
           <a:prstGeom prst="rect">
@@ -9228,7 +9324,7 @@
         </p:nvSpPr>
         <p:spPr>
           <a:xfrm>
-            <a:off x="4603750" y="3902472"/>
+            <a:off x="4603750" y="4142482"/>
             <a:ext cx="3074035" cy="505420"/>
           </a:xfrm>
           <a:prstGeom prst="rect">
@@ -9294,7 +9390,7 @@
         </p:nvSpPr>
         <p:spPr>
           <a:xfrm>
-            <a:off x="7978775" y="3373537"/>
+            <a:off x="7978775" y="3613547"/>
             <a:ext cx="3397250" cy="1215330"/>
           </a:xfrm>
           <a:prstGeom prst="roundRect">
@@ -9321,7 +9417,7 @@
         </p:nvSpPr>
         <p:spPr>
           <a:xfrm>
-            <a:off x="8185150" y="3579912"/>
+            <a:off x="8185150" y="3819922"/>
             <a:ext cx="3074035" cy="284460"/>
           </a:xfrm>
           <a:prstGeom prst="rect">
@@ -9365,7 +9461,7 @@
         </p:nvSpPr>
         <p:spPr>
           <a:xfrm>
-            <a:off x="8185150" y="3902472"/>
+            <a:off x="8185150" y="4142482"/>
             <a:ext cx="3074035" cy="505420"/>
           </a:xfrm>
           <a:prstGeom prst="rect">

</xml_diff>

<commit_message>
docs: re-export the slides with JUnit 6, revocation limits and the revoked verdict
</commit_message>
<xml_diff>
--- a/docs/PDF-Inspector-TFM.pptx
+++ b/docs/PDF-Inspector-TFM.pptx
@@ -3217,7 +3217,7 @@
         </p:nvGraphicFramePr>
         <p:xfrm>
           <a:off x="825500" y="1983581"/>
-          <a:ext cx="10553700" cy="3074690"/>
+          <a:ext cx="10553700" cy="3359150"/>
         </p:xfrm>
         <a:graphic>
           <a:graphicData uri="http://schemas.openxmlformats.org/drawingml/2006/table">
@@ -4500,7 +4500,7 @@
                   </a:tcPr>
                 </a:tc>
               </a:tr>
-              <a:tr h="439241">
+              <a:tr h="723702">
                 <a:tc>
                   <a:txBody>
                     <a:bodyPr/>
@@ -4589,7 +4589,7 @@
                           <a:ea typeface="IBM Plex Sans" pitchFamily="34" charset="-122"/>
                           <a:cs typeface="IBM Plex Sans" pitchFamily="34" charset="-120"/>
                         </a:rPr>
-                        <a:t>JUnit 5, AssertJ, Mockito, ArchUnit</a:t>
+                        <a:t>JUnit 6, AssertJ, Mockito, ArchUnit</a:t>
                       </a:r>
                       <a:endParaRPr lang="en-US" sz="1600" dirty="0">
                         <a:latin typeface="IBM Plex Sans" charset="0"/>
@@ -4657,7 +4657,7 @@
                           <a:ea typeface="IBM Plex Sans" pitchFamily="34" charset="-122"/>
                           <a:cs typeface="IBM Plex Sans" pitchFamily="34" charset="-120"/>
                         </a:rPr>
-                        <a:t>ArchUnit 1.5.1</a:t>
+                        <a:t>JUnit 6.0.3 · ArchUnit 1.5.1</a:t>
                       </a:r>
                       <a:endParaRPr lang="en-US" sz="1600" dirty="0">
                         <a:latin typeface="IBM Plex Sans" charset="0"/>
@@ -9139,11 +9139,11 @@
         <p:spPr>
           <a:xfrm>
             <a:off x="815975" y="3613547"/>
-            <a:ext cx="3397250" cy="1215330"/>
+            <a:ext cx="3397250" cy="1455341"/>
           </a:xfrm>
           <a:prstGeom prst="roundRect">
             <a:avLst>
-              <a:gd name="adj" fmla="val 8099"/>
+              <a:gd name="adj" fmla="val 6763"/>
             </a:avLst>
           </a:prstGeom>
           <a:solidFill>
@@ -9210,7 +9210,7 @@
         <p:spPr>
           <a:xfrm>
             <a:off x="1022350" y="4142482"/>
-            <a:ext cx="3074035" cy="505420"/>
+            <a:ext cx="3074035" cy="745430"/>
           </a:xfrm>
           <a:prstGeom prst="rect">
             <a:avLst/>
@@ -9239,7 +9239,7 @@
                 <a:ea typeface="IBM Plex Sans" pitchFamily="34" charset="-122"/>
                 <a:cs typeface="IBM Plex Sans" pitchFamily="34" charset="-120"/>
               </a:rPr>
-              <a:t>OCSP y CRL, opcional y con tiempo máximo de 2 s.</a:t>
+              <a:t>OCSP y CRL de toda la cadena, opcional: 2 s por consulta y 6 s por firma.</a:t>
             </a:r>
             <a:endParaRPr lang="en-US" sz="1400" dirty="0"/>
           </a:p>
@@ -9254,11 +9254,11 @@
         <p:spPr>
           <a:xfrm>
             <a:off x="4397375" y="3613547"/>
-            <a:ext cx="3397250" cy="1215330"/>
+            <a:ext cx="3397250" cy="1455341"/>
           </a:xfrm>
           <a:prstGeom prst="roundRect">
             <a:avLst>
-              <a:gd name="adj" fmla="val 8099"/>
+              <a:gd name="adj" fmla="val 6763"/>
             </a:avLst>
           </a:prstGeom>
           <a:solidFill>
@@ -9391,11 +9391,11 @@
         <p:spPr>
           <a:xfrm>
             <a:off x="7978775" y="3613547"/>
-            <a:ext cx="3397250" cy="1215330"/>
+            <a:ext cx="3397250" cy="1455341"/>
           </a:xfrm>
           <a:prstGeom prst="roundRect">
             <a:avLst>
-              <a:gd name="adj" fmla="val 8099"/>
+              <a:gd name="adj" fmla="val 6763"/>
             </a:avLst>
           </a:prstGeom>
           <a:solidFill>
@@ -11536,7 +11536,7 @@
                 <a:ea typeface="IBM Plex Sans" pitchFamily="34" charset="-122"/>
                 <a:cs typeface="IBM Plex Sans" pitchFamily="34" charset="-120"/>
               </a:rPr>
-              <a:t>: firma inválida o documento modificado.</a:t>
+              <a:t>: firma inválida, documento modificado o certificado revocado.</a:t>
             </a:r>
             <a:endParaRPr lang="en-US" sz="1800" dirty="0"/>
           </a:p>

</xml_diff>